<commit_message>
Fix stale-figure CI failure: drop superseded gas values quoted in deck/README.md
The README key-results gas table is current on the merged trunk (545,101 /
1,757,893, register #25). The earlier note that it was stale came from the
pre-merge README and was wrong; it is removed from deck/README.md,
VISUAL_PLAN.md and the gas slide's speaker notes (deck rebuilt; validator
passes). check_docs_numbers.py: 0 stale figures.

Co-Authored-By: Claude Opus 5.5 <noreply@anthropic.com>
Claude-Session: https://claude.ai/code/session_013Sv1PRc8vmKS5iCv7ExQds
</commit_message>
<xml_diff>
--- a/docs/visual/deck/cvin_v2v_defence.pptx
+++ b/docs/visual/deck/cvin_v2v_defence.pptx
@@ -118,23 +118,23 @@
   <p:extLst>
     <p:ext uri="{521415D9-36F7-43E2-AB2F-B90AF26B5E84}">
       <p14:sectionLst xmlns:p14="http://schemas.microsoft.com/office/powerpoint/2010/main">
-        <p14:section name="Opening" id="{65f73f9c-62b1-b79e-f29e-813dd9c4358e}">
+        <p14:section name="Opening" id="{8224d1e4-6865-57e8-0685-1a34ab70d57c}">
           <p14:sldIdLst>
             <p14:sldId id="256"/>
           </p14:sldIdLst>
         </p14:section>
-        <p14:section name="Questions" id="{c3f34301-4704-1ad8-531a-7fbcde899807}">
+        <p14:section name="Questions" id="{49cc2b70-db03-6c76-195e-91756454b94d}">
           <p14:sldIdLst>
             <p14:sldId id="257"/>
           </p14:sldIdLst>
         </p14:section>
-        <p14:section name="The message path" id="{56f7c785-17fc-6c1a-6138-a9aeeb87c489}">
+        <p14:section name="The message path" id="{f60e40f0-e052-87a5-a8a1-174baf46495b}">
           <p14:sldIdLst>
             <p14:sldId id="258"/>
             <p14:sldId id="259"/>
           </p14:sldIdLst>
         </p14:section>
-        <p14:section name="Results" id="{ca68639d-d317-8763-d8bd-52bf0a9d3299}">
+        <p14:section name="Results" id="{e35c1bd1-971e-ce78-1e9c-3549a8dccdde}">
           <p14:sldIdLst>
             <p14:sldId id="260"/>
             <p14:sldId id="261"/>
@@ -144,7 +144,7 @@
             <p14:sldId id="265"/>
           </p14:sldIdLst>
         </p14:section>
-        <p14:section name="Close" id="{8f5ce35d-f568-a734-92bb-a0beda644911}">
+        <p14:section name="Close" id="{f211f1a3-0991-6d3a-e555-e7374fc2348e}">
           <p14:sldIdLst>
             <p14:sldId id="266"/>
             <p14:sldId id="267"/>
@@ -953,7 +953,7 @@
           <a:p>
             <a:r>
               <a:rPr lang="en-US" dirty="0"/>
-              <a:t>Native chart from the results of record. The README key-results table still shows pre-2026-10-09 cells for ERC-721, ERC-735, ERC-1155, LSP8 and MOBI-VID-V2; this chart follows the results file and register #25.</a:t>
+              <a:t>Native chart from the results of record (gas_benchmark.json, register #25); the README key-results table carries the same values.</a:t>
             </a:r>
             <a:endParaRPr lang="en-US" dirty="0"/>
           </a:p>

</xml_diff>